<commit_message>
feat: harden mobile infographic craft and P18 evidence
</commit_message>
<xml_diff>
--- a/examples/p18-synthetic-output-pack/renders/final/reopened/synthetic-executive-briefing.pptx
+++ b/examples/p18-synthetic-output-pack/renders/final/reopened/synthetic-executive-briefing.pptx
@@ -306,7 +306,7 @@
               </a:lnSpc>
               <a:buNone/>
             </a:pPr>
-            <a:fld id="{64987FCA-15DD-40E9-90C8-26D9F1D291B4}" type="slidenum">
+            <a:fld id="{4B6E1D1F-AED3-4381-87F9-FD7F3B67FBFD}" type="slidenum">
               <a:rPr lang="en-US" sz="1200" b="0" u="none" strike="noStrike">
                 <a:solidFill>
                   <a:schemeClr val="dk1">
@@ -1015,7 +1015,7 @@
               </a:lnSpc>
               <a:buNone/>
             </a:pPr>
-            <a:fld id="{780B2530-C07E-47C3-9A6B-AADBB6E58DF6}" type="slidenum">
+            <a:fld id="{0BE00664-93BC-4464-AB29-1ACA2376814C}" type="slidenum">
               <a:rPr lang="en-US" sz="1200" b="0" u="none" strike="noStrike">
                 <a:solidFill>
                   <a:schemeClr val="dk1">
@@ -1810,7 +1810,7 @@
               </a:lnSpc>
               <a:buNone/>
             </a:pPr>
-            <a:fld id="{3370EEBE-0AE3-4D4A-9820-F2B25E4FB53E}" type="slidenum">
+            <a:fld id="{568E3C3C-15A1-405B-BA61-CD4C69BB2322}" type="slidenum">
               <a:rPr lang="en-US" sz="1200" b="0" u="none" strike="noStrike">
                 <a:solidFill>
                   <a:schemeClr val="dk1">
@@ -2435,7 +2435,7 @@
               </a:lnSpc>
               <a:buNone/>
             </a:pPr>
-            <a:fld id="{326DBD13-B143-4FEE-9EC2-CDC1B41D1C69}" type="slidenum">
+            <a:fld id="{459E7433-8319-4D1E-A025-26F9C74F89F1}" type="slidenum">
               <a:rPr lang="en-US" sz="1200" b="0" u="none" strike="noStrike">
                 <a:solidFill>
                   <a:schemeClr val="dk1">
@@ -3060,7 +3060,7 @@
               </a:lnSpc>
               <a:buNone/>
             </a:pPr>
-            <a:fld id="{730F9863-FB51-4DA9-A2D3-363D6DD7A7D4}" type="slidenum">
+            <a:fld id="{C4C04D3D-50DF-4A50-B409-A9566B20B751}" type="slidenum">
               <a:rPr lang="en-US" sz="1200" b="0" u="none" strike="noStrike">
                 <a:solidFill>
                   <a:schemeClr val="dk1">
@@ -3685,7 +3685,7 @@
               </a:lnSpc>
               <a:buNone/>
             </a:pPr>
-            <a:fld id="{0DE5E218-622D-4058-AB9E-B14BE030FE19}" type="slidenum">
+            <a:fld id="{9B8119A4-C14B-47DD-AD30-7D568FF9B273}" type="slidenum">
               <a:rPr lang="en-US" sz="1200" b="0" u="none" strike="noStrike">
                 <a:solidFill>
                   <a:schemeClr val="dk1">
@@ -4094,7 +4094,7 @@
               </a:lnSpc>
               <a:buNone/>
             </a:pPr>
-            <a:fld id="{190C0623-D516-4F84-B4D5-58F61CFC2D68}" type="slidenum">
+            <a:fld id="{C9D71C35-0BCB-4505-BDA3-010D9F2E7B14}" type="slidenum">
               <a:rPr lang="en-US" sz="1200" b="0" u="none" strike="noStrike">
                 <a:solidFill>
                   <a:schemeClr val="dk1">
@@ -5025,7 +5025,7 @@
               </a:lnSpc>
               <a:buNone/>
             </a:pPr>
-            <a:fld id="{389F37A6-8C91-4FAA-8E75-3B26C7C3C0BB}" type="slidenum">
+            <a:fld id="{0F6B34F6-EE0E-4DD6-A3EF-D71F9F76E66F}" type="slidenum">
               <a:rPr lang="en-US" sz="1200" b="0" u="none" strike="noStrike">
                 <a:solidFill>
                   <a:schemeClr val="dk1">
@@ -6184,7 +6184,7 @@
               </a:lnSpc>
               <a:buNone/>
             </a:pPr>
-            <a:fld id="{1D583F41-DF18-4EEA-B467-0AD84000FB8D}" type="slidenum">
+            <a:fld id="{C98DC871-6246-4973-B734-0E7B72A13A23}" type="slidenum">
               <a:rPr lang="en-US" sz="1200" b="0" u="none" strike="noStrike">
                 <a:solidFill>
                   <a:schemeClr val="dk1">
@@ -6503,7 +6503,7 @@
               </a:lnSpc>
               <a:buNone/>
             </a:pPr>
-            <a:fld id="{25F5C7D7-BE69-4E65-9220-986006FA1B52}" type="slidenum">
+            <a:fld id="{A45370C3-FC1D-4418-BE89-39D60212B841}" type="slidenum">
               <a:rPr lang="en-US" sz="1200" b="0" u="none" strike="noStrike">
                 <a:solidFill>
                   <a:schemeClr val="dk1">
@@ -6750,7 +6750,7 @@
               </a:lnSpc>
               <a:buNone/>
             </a:pPr>
-            <a:fld id="{68817A89-C576-40B8-87BB-C4D230EACFA1}" type="slidenum">
+            <a:fld id="{F053AE2D-ECD4-43D5-A152-08D6CCF92F27}" type="slidenum">
               <a:rPr lang="en-US" sz="1200" b="0" u="none" strike="noStrike">
                 <a:solidFill>
                   <a:schemeClr val="dk1">
@@ -9029,7 +9029,7 @@
       </p:sp>
       <p:pic>
         <p:nvPicPr>
-          <p:cNvPr id="90" name="Picture 3" descr="Three-case synthetic comparison of gap beyond an assumed 75 SCU buffer: 0 SCU with no lag, 0 SCU with a one-period lag, 45 SCU with a two-period lag."/>
+          <p:cNvPr id="90" name="Picture 3" descr="Three-case synthetic comparison of the gap beyond an assumed 75 SCU buffer. 0-period lag: 0 SCU; 1-period lag: 0 SCU; 2-period lag: 45 SCU."/>
           <p:cNvPicPr/>
           <p:nvPr/>
         </p:nvPicPr>

</xml_diff>